<commit_message>
chore: sync OPC projects snapshots
</commit_message>
<xml_diff>
--- a/OPC4-Auditez_un_environnement_de_donnees/docs/slides/Template+de+support+de+présentation+(1).pptx
+++ b/OPC4-Auditez_un_environnement_de_donnees/docs/slides/Template+de+support+de+présentation+(1).pptx
@@ -1801,7 +1801,7 @@
         </p:nvSpPr>
         <p:spPr>
           <a:xfrm>
-            <a:off x="381300" y="685800"/>
+            <a:off x="381000" y="685800"/>
             <a:ext cx="6096000" cy="3429000"/>
           </a:xfrm>
           <a:custGeom>
@@ -2009,7 +2009,7 @@
         </p:nvSpPr>
         <p:spPr>
           <a:xfrm>
-            <a:off x="381300" y="685800"/>
+            <a:off x="381000" y="685800"/>
             <a:ext cx="6096000" cy="3429000"/>
           </a:xfrm>
           <a:custGeom>
@@ -2113,7 +2113,7 @@
         </p:nvSpPr>
         <p:spPr>
           <a:xfrm>
-            <a:off x="381300" y="685800"/>
+            <a:off x="381000" y="685800"/>
             <a:ext cx="6096000" cy="3429000"/>
           </a:xfrm>
           <a:custGeom>
@@ -2217,7 +2217,7 @@
         </p:nvSpPr>
         <p:spPr>
           <a:xfrm>
-            <a:off x="381300" y="685800"/>
+            <a:off x="381000" y="685800"/>
             <a:ext cx="6096000" cy="3429000"/>
           </a:xfrm>
           <a:custGeom>
@@ -2321,7 +2321,7 @@
         </p:nvSpPr>
         <p:spPr>
           <a:xfrm>
-            <a:off x="381300" y="685800"/>
+            <a:off x="381000" y="685800"/>
             <a:ext cx="6096000" cy="3429000"/>
           </a:xfrm>
           <a:custGeom>
@@ -11677,10 +11677,40 @@
               <a:buFont typeface="Inter"/>
               <a:buChar char="●"/>
             </a:pPr>
-            <a:endParaRPr/>
+            <a:endParaRPr dirty="0"/>
           </a:p>
         </p:txBody>
       </p:sp>
+      <p:pic>
+        <p:nvPicPr>
+          <p:cNvPr id="2" name="Image 1" descr="https://s3.eu-west-1.amazonaws.com/course.oc-static.com/projects/922_Data+Engineer/922_P4/Sche%CC%81ma+architecture+.jpg">
+            <a:extLst>
+              <a:ext uri="{FF2B5EF4-FFF2-40B4-BE49-F238E27FC236}">
+                <a16:creationId xmlns:a16="http://schemas.microsoft.com/office/drawing/2014/main" id="{3A787A0B-B727-1B9D-E820-B20B5F0769D8}"/>
+              </a:ext>
+            </a:extLst>
+          </p:cNvPr>
+          <p:cNvPicPr>
+            <a:picLocks noChangeAspect="1"/>
+          </p:cNvPicPr>
+          <p:nvPr/>
+        </p:nvPicPr>
+        <p:blipFill>
+          <a:blip r:embed="rId3"/>
+          <a:stretch>
+            <a:fillRect/>
+          </a:stretch>
+        </p:blipFill>
+        <p:spPr>
+          <a:xfrm>
+            <a:off x="1581150" y="1857952"/>
+            <a:ext cx="5981700" cy="1428750"/>
+          </a:xfrm>
+          <a:prstGeom prst="rect">
+            <a:avLst/>
+          </a:prstGeom>
+        </p:spPr>
+      </p:pic>
     </p:spTree>
   </p:cSld>
   <p:clrMapOvr>
@@ -12000,10 +12030,129 @@
               <a:buFont typeface="Inter"/>
               <a:buChar char="●"/>
             </a:pPr>
-            <a:endParaRPr/>
+            <a:r>
+              <a:rPr lang="fr-FR" dirty="0"/>
+              <a:t>Unification de toute les dates en INT</a:t>
+            </a:r>
+          </a:p>
+          <a:p>
+            <a:pPr marL="457200" marR="152400" lvl="0" indent="-285750" algn="l" rtl="0">
+              <a:spcBef>
+                <a:spcPts val="0"/>
+              </a:spcBef>
+              <a:spcAft>
+                <a:spcPts val="0"/>
+              </a:spcAft>
+              <a:buClr>
+                <a:srgbClr val="999999"/>
+              </a:buClr>
+              <a:buSzPts val="900"/>
+              <a:buFont typeface="Inter"/>
+              <a:buChar char="●"/>
+            </a:pPr>
+            <a:r>
+              <a:rPr lang="fr-FR" dirty="0"/>
+              <a:t>Colonnes de calendrier calculée sur </a:t>
+            </a:r>
+            <a:r>
+              <a:rPr lang="fr-FR" dirty="0" err="1"/>
+              <a:t>date_id</a:t>
+            </a:r>
+            <a:endParaRPr lang="fr-FR" dirty="0"/>
+          </a:p>
+          <a:p>
+            <a:pPr marL="457200" marR="152400" lvl="0" indent="-285750" algn="l" rtl="0">
+              <a:spcBef>
+                <a:spcPts val="0"/>
+              </a:spcBef>
+              <a:spcAft>
+                <a:spcPts val="0"/>
+              </a:spcAft>
+              <a:buClr>
+                <a:srgbClr val="999999"/>
+              </a:buClr>
+              <a:buSzPts val="900"/>
+              <a:buFont typeface="Inter"/>
+              <a:buChar char="●"/>
+            </a:pPr>
+            <a:r>
+              <a:rPr lang="fr-FR" dirty="0" err="1"/>
+              <a:t>produits.ean</a:t>
+            </a:r>
+            <a:r>
+              <a:rPr lang="fr-FR" dirty="0"/>
+              <a:t> : DOUBLE</a:t>
+            </a:r>
+          </a:p>
+          <a:p>
+            <a:pPr marL="457200" marR="152400" lvl="0" indent="-285750" algn="l" rtl="0">
+              <a:spcBef>
+                <a:spcPts val="0"/>
+              </a:spcBef>
+              <a:spcAft>
+                <a:spcPts val="0"/>
+              </a:spcAft>
+              <a:buClr>
+                <a:srgbClr val="999999"/>
+              </a:buClr>
+              <a:buSzPts val="900"/>
+              <a:buFont typeface="Inter"/>
+              <a:buChar char="●"/>
+            </a:pPr>
+            <a:r>
+              <a:rPr lang="fr-FR" dirty="0"/>
+              <a:t>Mail et pseudo employé calculé</a:t>
+            </a:r>
+          </a:p>
+          <a:p>
+            <a:pPr marL="457200" marR="152400" lvl="0" indent="-285750" algn="l" rtl="0">
+              <a:spcBef>
+                <a:spcPts val="0"/>
+              </a:spcBef>
+              <a:spcAft>
+                <a:spcPts val="0"/>
+              </a:spcAft>
+              <a:buClr>
+                <a:srgbClr val="999999"/>
+              </a:buClr>
+              <a:buSzPts val="900"/>
+              <a:buFont typeface="Inter"/>
+              <a:buChar char="●"/>
+            </a:pPr>
+            <a:endParaRPr lang="fr-FR" dirty="0"/>
           </a:p>
         </p:txBody>
       </p:sp>
+      <p:pic>
+        <p:nvPicPr>
+          <p:cNvPr id="5" name="Image 4">
+            <a:extLst>
+              <a:ext uri="{FF2B5EF4-FFF2-40B4-BE49-F238E27FC236}">
+                <a16:creationId xmlns:a16="http://schemas.microsoft.com/office/drawing/2014/main" id="{D006A249-707D-FCFD-0515-9641BAA01AB6}"/>
+              </a:ext>
+            </a:extLst>
+          </p:cNvPr>
+          <p:cNvPicPr>
+            <a:picLocks noChangeAspect="1"/>
+          </p:cNvPicPr>
+          <p:nvPr/>
+        </p:nvPicPr>
+        <p:blipFill>
+          <a:blip r:embed="rId3"/>
+          <a:stretch>
+            <a:fillRect/>
+          </a:stretch>
+        </p:blipFill>
+        <p:spPr>
+          <a:xfrm>
+            <a:off x="5224605" y="1567550"/>
+            <a:ext cx="3111795" cy="2911200"/>
+          </a:xfrm>
+          <a:prstGeom prst="rect">
+            <a:avLst/>
+          </a:prstGeom>
+        </p:spPr>
+      </p:pic>
     </p:spTree>
   </p:cSld>
   <p:clrMapOvr>
@@ -12031,49 +12180,6 @@
       </p:grpSpPr>
       <p:sp>
         <p:nvSpPr>
-          <p:cNvPr id="170" name="Google Shape;170;p19"/>
-          <p:cNvSpPr txBox="1">
-            <a:spLocks noGrp="1"/>
-          </p:cNvSpPr>
-          <p:nvPr>
-            <p:ph type="body" idx="1"/>
-          </p:nvPr>
-        </p:nvSpPr>
-        <p:spPr>
-          <a:xfrm>
-            <a:off x="1297500" y="1567550"/>
-            <a:ext cx="7038900" cy="2911200"/>
-          </a:xfrm>
-          <a:prstGeom prst="rect">
-            <a:avLst/>
-          </a:prstGeom>
-        </p:spPr>
-        <p:txBody>
-          <a:bodyPr spcFirstLastPara="1" wrap="square" lIns="91425" tIns="91425" rIns="91425" bIns="91425" anchor="t" anchorCtr="0">
-            <a:normAutofit/>
-          </a:bodyPr>
-          <a:lstStyle/>
-          <a:p>
-            <a:pPr marL="457200" marR="152400" lvl="0" indent="-285750" algn="l" rtl="0">
-              <a:spcBef>
-                <a:spcPts val="0"/>
-              </a:spcBef>
-              <a:spcAft>
-                <a:spcPts val="0"/>
-              </a:spcAft>
-              <a:buClr>
-                <a:srgbClr val="999999"/>
-              </a:buClr>
-              <a:buSzPts val="900"/>
-              <a:buFont typeface="Inter"/>
-              <a:buChar char="●"/>
-            </a:pPr>
-            <a:endParaRPr/>
-          </a:p>
-        </p:txBody>
-      </p:sp>
-      <p:sp>
-        <p:nvSpPr>
           <p:cNvPr id="171" name="Google Shape;171;p19"/>
           <p:cNvSpPr txBox="1">
             <a:spLocks noGrp="1"/>
@@ -12083,10 +12189,6 @@
           </p:nvPr>
         </p:nvSpPr>
         <p:spPr>
-          <a:xfrm>
-            <a:off x="1297500" y="393750"/>
-            <a:ext cx="7038900" cy="914100"/>
-          </a:xfrm>
           <a:prstGeom prst="rect">
             <a:avLst/>
           </a:prstGeom>
@@ -12130,6 +12232,116 @@
           </a:p>
         </p:txBody>
       </p:sp>
+      <p:sp>
+        <p:nvSpPr>
+          <p:cNvPr id="2" name="Espace réservé du texte 1">
+            <a:extLst>
+              <a:ext uri="{FF2B5EF4-FFF2-40B4-BE49-F238E27FC236}">
+                <a16:creationId xmlns:a16="http://schemas.microsoft.com/office/drawing/2014/main" id="{0A6719DB-EE68-8F85-4857-0578C7AFC35C}"/>
+              </a:ext>
+            </a:extLst>
+          </p:cNvPr>
+          <p:cNvSpPr>
+            <a:spLocks noGrp="1"/>
+          </p:cNvSpPr>
+          <p:nvPr>
+            <p:ph type="body" idx="1"/>
+          </p:nvPr>
+        </p:nvSpPr>
+        <p:spPr/>
+        <p:txBody>
+          <a:bodyPr/>
+          <a:lstStyle/>
+          <a:p>
+            <a:endParaRPr lang="fr-FR" dirty="0"/>
+          </a:p>
+        </p:txBody>
+      </p:sp>
+      <p:sp>
+        <p:nvSpPr>
+          <p:cNvPr id="3" name="Espace réservé du texte 2">
+            <a:extLst>
+              <a:ext uri="{FF2B5EF4-FFF2-40B4-BE49-F238E27FC236}">
+                <a16:creationId xmlns:a16="http://schemas.microsoft.com/office/drawing/2014/main" id="{EC6FB080-B529-8864-8325-0C1307D2926E}"/>
+              </a:ext>
+            </a:extLst>
+          </p:cNvPr>
+          <p:cNvSpPr>
+            <a:spLocks noGrp="1"/>
+          </p:cNvSpPr>
+          <p:nvPr>
+            <p:ph type="body" idx="2"/>
+          </p:nvPr>
+        </p:nvSpPr>
+        <p:spPr/>
+        <p:txBody>
+          <a:bodyPr/>
+          <a:lstStyle/>
+          <a:p>
+            <a:endParaRPr lang="fr-FR" dirty="0"/>
+          </a:p>
+        </p:txBody>
+      </p:sp>
+      <p:pic>
+        <p:nvPicPr>
+          <p:cNvPr id="5" name="Image 4">
+            <a:extLst>
+              <a:ext uri="{FF2B5EF4-FFF2-40B4-BE49-F238E27FC236}">
+                <a16:creationId xmlns:a16="http://schemas.microsoft.com/office/drawing/2014/main" id="{EFC10D8A-6D84-0620-0220-0B7BA0BF6F7C}"/>
+              </a:ext>
+            </a:extLst>
+          </p:cNvPr>
+          <p:cNvPicPr>
+            <a:picLocks noChangeAspect="1"/>
+          </p:cNvPicPr>
+          <p:nvPr/>
+        </p:nvPicPr>
+        <p:blipFill>
+          <a:blip r:embed="rId3"/>
+          <a:stretch>
+            <a:fillRect/>
+          </a:stretch>
+        </p:blipFill>
+        <p:spPr>
+          <a:xfrm>
+            <a:off x="1297501" y="1567550"/>
+            <a:ext cx="3403200" cy="1200318"/>
+          </a:xfrm>
+          <a:prstGeom prst="rect">
+            <a:avLst/>
+          </a:prstGeom>
+        </p:spPr>
+      </p:pic>
+      <p:pic>
+        <p:nvPicPr>
+          <p:cNvPr id="7" name="Image 6">
+            <a:extLst>
+              <a:ext uri="{FF2B5EF4-FFF2-40B4-BE49-F238E27FC236}">
+                <a16:creationId xmlns:a16="http://schemas.microsoft.com/office/drawing/2014/main" id="{49DCAC60-9FF4-539E-7B08-F61EC4CEFF64}"/>
+              </a:ext>
+            </a:extLst>
+          </p:cNvPr>
+          <p:cNvPicPr>
+            <a:picLocks noChangeAspect="1"/>
+          </p:cNvPicPr>
+          <p:nvPr/>
+        </p:nvPicPr>
+        <p:blipFill>
+          <a:blip r:embed="rId4"/>
+          <a:stretch>
+            <a:fillRect/>
+          </a:stretch>
+        </p:blipFill>
+        <p:spPr>
+          <a:xfrm>
+            <a:off x="4933220" y="1567550"/>
+            <a:ext cx="3403180" cy="864300"/>
+          </a:xfrm>
+          <a:prstGeom prst="rect">
+            <a:avLst/>
+          </a:prstGeom>
+        </p:spPr>
+      </p:pic>
     </p:spTree>
   </p:cSld>
   <p:clrMapOvr>
@@ -12157,49 +12369,6 @@
       </p:grpSpPr>
       <p:sp>
         <p:nvSpPr>
-          <p:cNvPr id="176" name="Google Shape;176;p20"/>
-          <p:cNvSpPr txBox="1">
-            <a:spLocks noGrp="1"/>
-          </p:cNvSpPr>
-          <p:nvPr>
-            <p:ph type="body" idx="1"/>
-          </p:nvPr>
-        </p:nvSpPr>
-        <p:spPr>
-          <a:xfrm>
-            <a:off x="1297500" y="1567550"/>
-            <a:ext cx="7038900" cy="2911200"/>
-          </a:xfrm>
-          <a:prstGeom prst="rect">
-            <a:avLst/>
-          </a:prstGeom>
-        </p:spPr>
-        <p:txBody>
-          <a:bodyPr spcFirstLastPara="1" wrap="square" lIns="91425" tIns="91425" rIns="91425" bIns="91425" anchor="t" anchorCtr="0">
-            <a:normAutofit/>
-          </a:bodyPr>
-          <a:lstStyle/>
-          <a:p>
-            <a:pPr marL="457200" marR="152400" lvl="0" indent="-285750" algn="l" rtl="0">
-              <a:spcBef>
-                <a:spcPts val="0"/>
-              </a:spcBef>
-              <a:spcAft>
-                <a:spcPts val="0"/>
-              </a:spcAft>
-              <a:buClr>
-                <a:srgbClr val="999999"/>
-              </a:buClr>
-              <a:buSzPts val="900"/>
-              <a:buFont typeface="Inter"/>
-              <a:buChar char="●"/>
-            </a:pPr>
-            <a:endParaRPr/>
-          </a:p>
-        </p:txBody>
-      </p:sp>
-      <p:sp>
-        <p:nvSpPr>
           <p:cNvPr id="177" name="Google Shape;177;p20"/>
           <p:cNvSpPr txBox="1">
             <a:spLocks noGrp="1"/>
@@ -12209,10 +12378,6 @@
           </p:nvPr>
         </p:nvSpPr>
         <p:spPr>
-          <a:xfrm>
-            <a:off x="1297500" y="393750"/>
-            <a:ext cx="7038900" cy="914100"/>
-          </a:xfrm>
           <a:prstGeom prst="rect">
             <a:avLst/>
           </a:prstGeom>
@@ -12256,6 +12421,116 @@
           </a:p>
         </p:txBody>
       </p:sp>
+      <p:sp>
+        <p:nvSpPr>
+          <p:cNvPr id="2" name="Espace réservé du texte 1">
+            <a:extLst>
+              <a:ext uri="{FF2B5EF4-FFF2-40B4-BE49-F238E27FC236}">
+                <a16:creationId xmlns:a16="http://schemas.microsoft.com/office/drawing/2014/main" id="{D6FAF3E9-497F-C9D3-737C-12C210EAA5B6}"/>
+              </a:ext>
+            </a:extLst>
+          </p:cNvPr>
+          <p:cNvSpPr>
+            <a:spLocks noGrp="1"/>
+          </p:cNvSpPr>
+          <p:nvPr>
+            <p:ph type="body" idx="1"/>
+          </p:nvPr>
+        </p:nvSpPr>
+        <p:spPr/>
+        <p:txBody>
+          <a:bodyPr/>
+          <a:lstStyle/>
+          <a:p>
+            <a:endParaRPr lang="fr-FR" dirty="0"/>
+          </a:p>
+        </p:txBody>
+      </p:sp>
+      <p:sp>
+        <p:nvSpPr>
+          <p:cNvPr id="3" name="Espace réservé du texte 2">
+            <a:extLst>
+              <a:ext uri="{FF2B5EF4-FFF2-40B4-BE49-F238E27FC236}">
+                <a16:creationId xmlns:a16="http://schemas.microsoft.com/office/drawing/2014/main" id="{02BD4FFE-F851-5FA1-9F5F-15904E82BB49}"/>
+              </a:ext>
+            </a:extLst>
+          </p:cNvPr>
+          <p:cNvSpPr>
+            <a:spLocks noGrp="1"/>
+          </p:cNvSpPr>
+          <p:nvPr>
+            <p:ph type="body" idx="2"/>
+          </p:nvPr>
+        </p:nvSpPr>
+        <p:spPr/>
+        <p:txBody>
+          <a:bodyPr/>
+          <a:lstStyle/>
+          <a:p>
+            <a:endParaRPr lang="fr-FR" dirty="0"/>
+          </a:p>
+        </p:txBody>
+      </p:sp>
+      <p:pic>
+        <p:nvPicPr>
+          <p:cNvPr id="5" name="Image 4">
+            <a:extLst>
+              <a:ext uri="{FF2B5EF4-FFF2-40B4-BE49-F238E27FC236}">
+                <a16:creationId xmlns:a16="http://schemas.microsoft.com/office/drawing/2014/main" id="{17C5F8F3-EA4C-DF43-8EA7-9F12390DFA4A}"/>
+              </a:ext>
+            </a:extLst>
+          </p:cNvPr>
+          <p:cNvPicPr>
+            <a:picLocks noChangeAspect="1"/>
+          </p:cNvPicPr>
+          <p:nvPr/>
+        </p:nvPicPr>
+        <p:blipFill>
+          <a:blip r:embed="rId3"/>
+          <a:stretch>
+            <a:fillRect/>
+          </a:stretch>
+        </p:blipFill>
+        <p:spPr>
+          <a:xfrm>
+            <a:off x="1297499" y="1567550"/>
+            <a:ext cx="3403787" cy="1720595"/>
+          </a:xfrm>
+          <a:prstGeom prst="rect">
+            <a:avLst/>
+          </a:prstGeom>
+        </p:spPr>
+      </p:pic>
+      <p:pic>
+        <p:nvPicPr>
+          <p:cNvPr id="7" name="Image 6">
+            <a:extLst>
+              <a:ext uri="{FF2B5EF4-FFF2-40B4-BE49-F238E27FC236}">
+                <a16:creationId xmlns:a16="http://schemas.microsoft.com/office/drawing/2014/main" id="{E3021046-D9D6-B4A2-AAA2-8AE590A804E5}"/>
+              </a:ext>
+            </a:extLst>
+          </p:cNvPr>
+          <p:cNvPicPr>
+            <a:picLocks noChangeAspect="1"/>
+          </p:cNvPicPr>
+          <p:nvPr/>
+        </p:nvPicPr>
+        <p:blipFill>
+          <a:blip r:embed="rId4"/>
+          <a:stretch>
+            <a:fillRect/>
+          </a:stretch>
+        </p:blipFill>
+        <p:spPr>
+          <a:xfrm>
+            <a:off x="4933221" y="1567550"/>
+            <a:ext cx="3403179" cy="1901266"/>
+          </a:xfrm>
+          <a:prstGeom prst="rect">
+            <a:avLst/>
+          </a:prstGeom>
+        </p:spPr>
+      </p:pic>
     </p:spTree>
   </p:cSld>
   <p:clrMapOvr>
@@ -12283,49 +12558,6 @@
       </p:grpSpPr>
       <p:sp>
         <p:nvSpPr>
-          <p:cNvPr id="182" name="Google Shape;182;p21"/>
-          <p:cNvSpPr txBox="1">
-            <a:spLocks noGrp="1"/>
-          </p:cNvSpPr>
-          <p:nvPr>
-            <p:ph type="body" idx="1"/>
-          </p:nvPr>
-        </p:nvSpPr>
-        <p:spPr>
-          <a:xfrm>
-            <a:off x="1297500" y="1567550"/>
-            <a:ext cx="7038900" cy="2911200"/>
-          </a:xfrm>
-          <a:prstGeom prst="rect">
-            <a:avLst/>
-          </a:prstGeom>
-        </p:spPr>
-        <p:txBody>
-          <a:bodyPr spcFirstLastPara="1" wrap="square" lIns="91425" tIns="91425" rIns="91425" bIns="91425" anchor="t" anchorCtr="0">
-            <a:normAutofit/>
-          </a:bodyPr>
-          <a:lstStyle/>
-          <a:p>
-            <a:pPr marL="457200" marR="152400" lvl="0" indent="-285750" algn="l" rtl="0">
-              <a:spcBef>
-                <a:spcPts val="0"/>
-              </a:spcBef>
-              <a:spcAft>
-                <a:spcPts val="0"/>
-              </a:spcAft>
-              <a:buClr>
-                <a:srgbClr val="999999"/>
-              </a:buClr>
-              <a:buSzPts val="900"/>
-              <a:buFont typeface="Inter"/>
-              <a:buChar char="●"/>
-            </a:pPr>
-            <a:endParaRPr/>
-          </a:p>
-        </p:txBody>
-      </p:sp>
-      <p:sp>
-        <p:nvSpPr>
           <p:cNvPr id="183" name="Google Shape;183;p21"/>
           <p:cNvSpPr txBox="1">
             <a:spLocks noGrp="1"/>
@@ -12335,10 +12567,6 @@
           </p:nvPr>
         </p:nvSpPr>
         <p:spPr>
-          <a:xfrm>
-            <a:off x="1297500" y="393750"/>
-            <a:ext cx="7038900" cy="914100"/>
-          </a:xfrm>
           <a:prstGeom prst="rect">
             <a:avLst/>
           </a:prstGeom>
@@ -12397,6 +12625,116 @@
           </a:p>
         </p:txBody>
       </p:sp>
+      <p:sp>
+        <p:nvSpPr>
+          <p:cNvPr id="2" name="Espace réservé du texte 1">
+            <a:extLst>
+              <a:ext uri="{FF2B5EF4-FFF2-40B4-BE49-F238E27FC236}">
+                <a16:creationId xmlns:a16="http://schemas.microsoft.com/office/drawing/2014/main" id="{C1EB5CA5-3D6D-9723-761F-2AD1B5EA78AF}"/>
+              </a:ext>
+            </a:extLst>
+          </p:cNvPr>
+          <p:cNvSpPr>
+            <a:spLocks noGrp="1"/>
+          </p:cNvSpPr>
+          <p:nvPr>
+            <p:ph type="body" idx="1"/>
+          </p:nvPr>
+        </p:nvSpPr>
+        <p:spPr/>
+        <p:txBody>
+          <a:bodyPr/>
+          <a:lstStyle/>
+          <a:p>
+            <a:endParaRPr lang="fr-FR" dirty="0"/>
+          </a:p>
+        </p:txBody>
+      </p:sp>
+      <p:sp>
+        <p:nvSpPr>
+          <p:cNvPr id="3" name="Espace réservé du texte 2">
+            <a:extLst>
+              <a:ext uri="{FF2B5EF4-FFF2-40B4-BE49-F238E27FC236}">
+                <a16:creationId xmlns:a16="http://schemas.microsoft.com/office/drawing/2014/main" id="{C2EB5010-A7E1-507D-B97A-F3EB084128D3}"/>
+              </a:ext>
+            </a:extLst>
+          </p:cNvPr>
+          <p:cNvSpPr>
+            <a:spLocks noGrp="1"/>
+          </p:cNvSpPr>
+          <p:nvPr>
+            <p:ph type="body" idx="2"/>
+          </p:nvPr>
+        </p:nvSpPr>
+        <p:spPr/>
+        <p:txBody>
+          <a:bodyPr/>
+          <a:lstStyle/>
+          <a:p>
+            <a:endParaRPr lang="fr-FR" dirty="0"/>
+          </a:p>
+        </p:txBody>
+      </p:sp>
+      <p:pic>
+        <p:nvPicPr>
+          <p:cNvPr id="5" name="Image 4">
+            <a:extLst>
+              <a:ext uri="{FF2B5EF4-FFF2-40B4-BE49-F238E27FC236}">
+                <a16:creationId xmlns:a16="http://schemas.microsoft.com/office/drawing/2014/main" id="{6B370919-C30B-A3B1-F2A4-D93D77FAFD25}"/>
+              </a:ext>
+            </a:extLst>
+          </p:cNvPr>
+          <p:cNvPicPr>
+            <a:picLocks noChangeAspect="1"/>
+          </p:cNvPicPr>
+          <p:nvPr/>
+        </p:nvPicPr>
+        <p:blipFill>
+          <a:blip r:embed="rId3"/>
+          <a:stretch>
+            <a:fillRect/>
+          </a:stretch>
+        </p:blipFill>
+        <p:spPr>
+          <a:xfrm>
+            <a:off x="1297499" y="1567550"/>
+            <a:ext cx="3403199" cy="1686541"/>
+          </a:xfrm>
+          <a:prstGeom prst="rect">
+            <a:avLst/>
+          </a:prstGeom>
+        </p:spPr>
+      </p:pic>
+      <p:pic>
+        <p:nvPicPr>
+          <p:cNvPr id="7" name="Image 6">
+            <a:extLst>
+              <a:ext uri="{FF2B5EF4-FFF2-40B4-BE49-F238E27FC236}">
+                <a16:creationId xmlns:a16="http://schemas.microsoft.com/office/drawing/2014/main" id="{A9BCE8A2-AD64-0672-C46D-C605BE9FB553}"/>
+              </a:ext>
+            </a:extLst>
+          </p:cNvPr>
+          <p:cNvPicPr>
+            <a:picLocks noChangeAspect="1"/>
+          </p:cNvPicPr>
+          <p:nvPr/>
+        </p:nvPicPr>
+        <p:blipFill>
+          <a:blip r:embed="rId4"/>
+          <a:stretch>
+            <a:fillRect/>
+          </a:stretch>
+        </p:blipFill>
+        <p:spPr>
+          <a:xfrm>
+            <a:off x="4933221" y="1567551"/>
+            <a:ext cx="3401561" cy="2487214"/>
+          </a:xfrm>
+          <a:prstGeom prst="rect">
+            <a:avLst/>
+          </a:prstGeom>
+        </p:spPr>
+      </p:pic>
     </p:spTree>
   </p:cSld>
   <p:clrMapOvr>

</xml_diff>